<commit_message>
docs: refine AI presentation v0.9 layout
</commit_message>
<xml_diff>
--- a/docs/report/ai-redefines-software-development-presentation/ai-redefines-software-development-v0.9.pptx
+++ b/docs/report/ai-redefines-software-development-presentation/ai-redefines-software-development-v0.9.pptx
@@ -513,7 +513,7 @@
           <a:p>
             <a:r>
               <a:rPr lang="en-US" dirty="0"/>
-              <a:t>第 1 页：AI 如何重新定义软件开发
+              <a:t>第 1 页：AI 重新定义开发
 建议时长：约 0.5 分钟
 讲述目标：建立主旨：AI 放大的不是单纯代码量，而是对工程治理系统的要求。
 可选提问：当代码生成不再是瓶颈，软件工程真正需要同步升级的是什么？
@@ -606,7 +606,7 @@
           <a:p>
             <a:r>
               <a:rPr lang="en-US" dirty="0"/>
-              <a:t>第 10 页：BitFun 演进：先锁能力，再迁边界
+              <a:t>第 10 页：能力演进
 建议时长：约 1.3 分钟
 讲述目标：把 BitFun 未来演进落到能力保护式重构：先锁能力，再设接口、查边界、验等价。
 可选提问：当 AI 让重构速度变快，团队如何避免把产品能力和平台边界拆散？
@@ -699,7 +699,7 @@
           <a:p>
             <a:r>
               <a:rPr lang="en-US" dirty="0"/>
-              <a:t>第 11 页：职责变化：团队建系统，个人守判断
+              <a:t>第 11 页：职责变化
 建议时长：约 1.7 分钟
 讲述目标：合并团队职责和个人职责：团队负责可治理交付系统，个人负责问题定义、事实核验、风险解释和责任承接。
 可选提问：AI 参与每个阶段后，哪些能力应该由团队系统承接，哪些判断必须由人站出来承担？
@@ -793,11 +793,11 @@
             <a:r>
               <a:rPr lang="en-US" dirty="0"/>
               <a:t>第 12 页：谢谢
-建议时长：约 0.9 分钟（收束 + Q&amp;A 入口）
-讲述目标：用三条外部研究引出的讨论问题收束，给 Q&amp;A 留入口。
-可选提问：如果 AI 已经进入日常开发，团队最应该先讨论收益、治理，还是人的判断位置？
-讲稿：最后我不把结论收成标准答案，而是留三个讨论入口。第一，Google 和 DeepMind 的 agent scaling 研究说明多 Agent 要按任务结构设计，那么我们在团队里该如何判断任务适合单 Agent、并行 Agent 还是集中编排。第二，IBM MAP 和 Gartner 的信号都指向生产化：真实企业更关心短链路、可控、人类评估、治理和验证平台，那么我们的工具建设如何从单点能力走向运行基座。第三，MSR 2026 提醒我们，速度提升需要质量机制承接，那么团队要如何把质量、返工率和维护收益纳入 AI 研发的收益计算。用一句话收束：AI 一定会持续重新定义软件开发，它带来的不是一次工具替换，而是一轮工程系统升级。周边工程能力、团队沟通方式和个人技能跟上以后，这份正收益会被持续放大。
-转场：进入 Q&amp;A。</a:t>
+建议时长：约 0.8 分钟
+讲述目标：回到简洁致谢页，用两个更落地的问题收束，不展开成方案页。
+可选提问：AI 研发正收益最应该先落在哪条工作流、哪组质量指标上？
+讲稿：最后简单收束成两个落地问题。第一，团队可以先选哪一条高频工作流，做任务入口、隔离环境、权限、评审材料和阶段门禁的控制面。第二，质量指标应该怎么前置，至少把等待、返工、失败重跑、测试证据和回滚说明纳入判断。AI 的方向是正收益，但真正落地时，要把这份正收益放到能衡量、能复盘、能持续改进的工程系统里。谢谢大家。
+转场：进入交流。</a:t>
             </a:r>
             <a:endParaRPr lang="en-US" dirty="0"/>
           </a:p>
@@ -978,7 +978,7 @@
           <a:p>
             <a:r>
               <a:rPr lang="en-US" dirty="0"/>
-              <a:t>第 3 页：单月 10W+ 行代码之后，速度从哪里来？
+              <a:t>第 3 页：速度的背后
 建议时长：约 1.3 分钟
 讲述目标：用 BitFun 统计说明速度来自反馈周期压缩，同时点明质量压力会转移到评审、持续集成、维护和上下文承接。
 可选提问：如果代码进入仓库更快了，团队怎样判断质量也在变好？
@@ -1071,7 +1071,7 @@
           <a:p>
             <a:r>
               <a:rPr lang="en-US" dirty="0"/>
-              <a:t>第 4 页：研究共识：从速度争议到 Agent 工程化
+              <a:t>第 4 页：行业探索
 建议时长：约 1.4 分钟
 讲述目标：用企业研究、顶会论文和行业判断提炼共识：AI 研发收益来自系统化承接，而不是单点工具采用。
 可选提问：为什么开发者感觉更快，团队整体交付却未必同等变快？
@@ -1164,7 +1164,7 @@
           <a:p>
             <a:r>
               <a:rPr lang="en-US" dirty="0"/>
-              <a:t>第 5 页：行业做法：把 Agent 放进工程流程
+              <a:t>第 5 页：工具的方向
 建议时长：约 1.3 分钟
 讲述目标：用 GitHub Copilot、Codex、Claude Code、Cursor 的官方能力归纳行业共识：从 IDE 助手走向可协作、可审计的 Agent 工作流。
 可选提问：主流工具面对 AI 生成代码的质量和协作问题，正在把能力往哪里放？
@@ -1257,7 +1257,7 @@
           <a:p>
             <a:r>
               <a:rPr lang="en-US" dirty="0"/>
-              <a:t>第 6 页：BitFun：把 AI 执行放进工程控制面
+              <a:t>第 6 页：工程控制面
 建议时长：约 1.4 分钟
 讲述目标：用 BitFun 本地工程机制说明运行基座不是概念，而是规则、工具、权限和验证的组合。
 可选提问：同样的模型，为什么放进不同工程系统里，可靠性会差很多？
@@ -1350,7 +1350,7 @@
           <a:p>
             <a:r>
               <a:rPr lang="en-US" dirty="0"/>
-              <a:t>第 7 页：从概率探索到确定放行
+              <a:t>第 7 页：确定性放行
 建议时长：约 1.4 分钟
 讲述目标：讲清楚概率过程与确定性中间件的分工：探索可以发散，放行必须收敛到证据和门禁。
 可选提问：如果 Agent 的每一步都可能波动，团队靠什么把最终交付变得可判断？
@@ -1443,7 +1443,7 @@
           <a:p>
             <a:r>
               <a:rPr lang="en-US" dirty="0"/>
-              <a:t>第 8 页：落地框架：从 Issue 到 PR 的可治理工作流
+              <a:t>第 8 页：可治理工作流
 建议时长：约 1.4 分钟
 讲述目标：给出一条可执行工作流：任务入口、隔离执行、判断上下文、独立评审、阶段放行。
 可选提问：如果多个 Agent 同时参与，团队靠什么判断一个变更可以继续前进？
@@ -1536,7 +1536,7 @@
           <a:p>
             <a:r>
               <a:rPr lang="en-US" dirty="0"/>
-              <a:t>第 9 页：质量协议：把检查面前置到工作流
+              <a:t>第 9 页：质量前置
 建议时长：约 1.4 分钟
 讲述目标：合并质量链路和工程协议：把责任、证据、工件三条链前置到任务、生成和合并节点，减少与速度页的重复。
 可选提问：哪些质量要求应该从文档和经验，变成工具可以检查、Agent 可以读取、人可以复核的规则？

</xml_diff>